<commit_message>
Update deck and research documentation
</commit_message>
<xml_diff>
--- a/deck/MuleShield_AI_SIH26184.pptx
+++ b/deck/MuleShield_AI_SIH26184.pptx
@@ -1,11 +1,11 @@
 
 <file path=ppt/presentation.xml><?xml version="1.0" encoding="utf-8"?>
-<p:presentation xmlns:a="http://schemas.openxmlformats.org/drawingml/2006/main" xmlns:r="http://schemas.openxmlformats.org/officeDocument/2006/relationships" xmlns:p="http://schemas.openxmlformats.org/presentationml/2006/main" showSpecialPlsOnTitleSld="0" saveSubsetFonts="1" autoCompressPictures="0">
+<p:presentation xmlns:p15="http://schemas.microsoft.com/office/powerpoint/2012/main" xmlns:a="http://schemas.openxmlformats.org/drawingml/2006/main" xmlns:r="http://schemas.openxmlformats.org/officeDocument/2006/relationships" xmlns:p="http://schemas.openxmlformats.org/presentationml/2006/main" showSpecialPlsOnTitleSld="0" saveSubsetFonts="1" autoCompressPictures="0">
   <p:sldMasterIdLst>
     <p:sldMasterId id="2147483648" r:id="rId1"/>
   </p:sldMasterIdLst>
   <p:notesMasterIdLst>
-    <p:notesMasterId r:id="rId8"/>
+    <p:notesMasterId r:id="rId9"/>
   </p:notesMasterIdLst>
   <p:sldIdLst>
     <p:sldId id="291" r:id="rId2"/>
@@ -261,7 +261,7 @@
             <a:fld id="{C4D5ADD5-2BBC-4A94-8F86-D9013941F742}" type="datetimeFigureOut">
               <a:rPr lang="en-US"/>
               <a:pPr/>
-              <a:t>8/31/2026</a:t>
+              <a:t>6/26/2025</a:t>
             </a:fld>
             <a:endParaRPr lang="en-US"/>
           </a:p>
@@ -1351,6 +1351,184 @@
 </p:notes>
 </file>
 
+<file path=ppt/notesSlides/notesSlide6.xml><?xml version="1.0" encoding="utf-8"?>
+<p:notes xmlns:a="http://schemas.openxmlformats.org/drawingml/2006/main" xmlns:r="http://schemas.openxmlformats.org/officeDocument/2006/relationships" xmlns:p="http://schemas.openxmlformats.org/presentationml/2006/main">
+  <p:cSld>
+    <p:spTree>
+      <p:nvGrpSpPr>
+        <p:cNvPr id="1" name=""/>
+        <p:cNvGrpSpPr/>
+        <p:nvPr/>
+      </p:nvGrpSpPr>
+      <p:grpSpPr>
+        <a:xfrm>
+          <a:off x="0" y="0"/>
+          <a:ext cx="0" cy="0"/>
+          <a:chOff x="0" y="0"/>
+          <a:chExt cx="0" cy="0"/>
+        </a:xfrm>
+      </p:grpSpPr>
+      <p:sp>
+        <p:nvSpPr>
+          <p:cNvPr id="18433" name="Slide Image Placeholder 1"/>
+          <p:cNvSpPr>
+            <a:spLocks noGrp="1" noRot="1" noChangeAspect="1"/>
+          </p:cNvSpPr>
+          <p:nvPr>
+            <p:ph type="sldImg"/>
+          </p:nvPr>
+        </p:nvSpPr>
+        <p:spPr bwMode="auto">
+          <a:xfrm>
+            <a:off x="381000" y="685800"/>
+            <a:ext cx="6096000" cy="3429000"/>
+          </a:xfrm>
+          <a:noFill/>
+          <a:ln>
+            <a:solidFill>
+              <a:srgbClr val="000000"/>
+            </a:solidFill>
+            <a:miter lim="800000"/>
+            <a:headEnd/>
+            <a:tailEnd/>
+          </a:ln>
+        </p:spPr>
+      </p:sp>
+      <p:sp>
+        <p:nvSpPr>
+          <p:cNvPr id="18434" name="Notes Placeholder 2"/>
+          <p:cNvSpPr>
+            <a:spLocks noGrp="1"/>
+          </p:cNvSpPr>
+          <p:nvPr>
+            <p:ph type="body" idx="1"/>
+          </p:nvPr>
+        </p:nvSpPr>
+        <p:spPr bwMode="auto">
+          <a:noFill/>
+        </p:spPr>
+        <p:txBody>
+          <a:bodyPr wrap="square" numCol="1" anchor="t" anchorCtr="0" compatLnSpc="1">
+            <a:prstTxWarp prst="textNoShape">
+              <a:avLst/>
+            </a:prstTxWarp>
+          </a:bodyPr>
+          <a:lstStyle/>
+          <a:p>
+            <a:pPr eaLnBrk="1" hangingPunct="1">
+              <a:spcBef>
+                <a:spcPct val="0"/>
+              </a:spcBef>
+            </a:pPr>
+            <a:endParaRPr lang="en-US">
+              <a:ea typeface="ＭＳ Ｐゴシック" pitchFamily="1" charset="-128"/>
+            </a:endParaRPr>
+          </a:p>
+        </p:txBody>
+      </p:sp>
+      <p:sp>
+        <p:nvSpPr>
+          <p:cNvPr id="18435" name="Slide Number Placeholder 3"/>
+          <p:cNvSpPr>
+            <a:spLocks noGrp="1"/>
+          </p:cNvSpPr>
+          <p:nvPr>
+            <p:ph type="sldNum" sz="quarter" idx="5"/>
+          </p:nvPr>
+        </p:nvSpPr>
+        <p:spPr bwMode="auto">
+          <a:noFill/>
+          <a:ln>
+            <a:miter lim="800000"/>
+            <a:headEnd/>
+            <a:tailEnd/>
+          </a:ln>
+        </p:spPr>
+        <p:txBody>
+          <a:bodyPr/>
+          <a:lstStyle/>
+          <a:p>
+            <a:pPr marL="0" marR="0" lvl="0" indent="0" algn="r" defTabSz="457200" rtl="0" eaLnBrk="1" fontAlgn="base" latinLnBrk="0" hangingPunct="1">
+              <a:lnSpc>
+                <a:spcPct val="100000"/>
+              </a:lnSpc>
+              <a:spcBef>
+                <a:spcPct val="0"/>
+              </a:spcBef>
+              <a:spcAft>
+                <a:spcPct val="0"/>
+              </a:spcAft>
+              <a:buClrTx/>
+              <a:buSzTx/>
+              <a:buFontTx/>
+              <a:buNone/>
+              <a:tabLst/>
+              <a:defRPr/>
+            </a:pPr>
+            <a:fld id="{0CA7B74D-3791-4AC6-8451-F10DBCCCDD9A}" type="slidenum">
+              <a:rPr kumimoji="0" lang="en-US" sz="1200" b="0" i="0" u="none" strike="noStrike" kern="1200" cap="none" spc="0" normalizeH="0" baseline="0" noProof="0">
+                <a:ln>
+                  <a:noFill/>
+                </a:ln>
+                <a:solidFill>
+                  <a:prstClr val="black"/>
+                </a:solidFill>
+                <a:effectLst/>
+                <a:uLnTx/>
+                <a:uFillTx/>
+                <a:latin typeface="Calibri" pitchFamily="34" charset="0"/>
+                <a:ea typeface="ＭＳ Ｐゴシック" pitchFamily="1" charset="-128"/>
+                <a:cs typeface="+mn-cs"/>
+              </a:rPr>
+              <a:pPr marL="0" marR="0" lvl="0" indent="0" algn="r" defTabSz="457200" rtl="0" eaLnBrk="1" fontAlgn="base" latinLnBrk="0" hangingPunct="1">
+                <a:lnSpc>
+                  <a:spcPct val="100000"/>
+                </a:lnSpc>
+                <a:spcBef>
+                  <a:spcPct val="0"/>
+                </a:spcBef>
+                <a:spcAft>
+                  <a:spcPct val="0"/>
+                </a:spcAft>
+                <a:buClrTx/>
+                <a:buSzTx/>
+                <a:buFontTx/>
+                <a:buNone/>
+                <a:tabLst/>
+                <a:defRPr/>
+              </a:pPr>
+              <a:t>7</a:t>
+            </a:fld>
+            <a:endParaRPr kumimoji="0" lang="en-US" sz="1200" b="0" i="0" u="none" strike="noStrike" kern="1200" cap="none" spc="0" normalizeH="0" baseline="0" noProof="0">
+              <a:ln>
+                <a:noFill/>
+              </a:ln>
+              <a:solidFill>
+                <a:prstClr val="black"/>
+              </a:solidFill>
+              <a:effectLst/>
+              <a:uLnTx/>
+              <a:uFillTx/>
+              <a:latin typeface="Calibri" pitchFamily="34" charset="0"/>
+              <a:ea typeface="ＭＳ Ｐゴシック" pitchFamily="1" charset="-128"/>
+              <a:cs typeface="+mn-cs"/>
+            </a:endParaRPr>
+          </a:p>
+        </p:txBody>
+      </p:sp>
+    </p:spTree>
+    <p:extLst>
+      <p:ext uri="{BB962C8B-B14F-4D97-AF65-F5344CB8AC3E}">
+        <p14:creationId xmlns:p14="http://schemas.microsoft.com/office/powerpoint/2010/main" val="3783576877"/>
+      </p:ext>
+    </p:extLst>
+  </p:cSld>
+  <p:clrMapOvr>
+    <a:masterClrMapping/>
+  </p:clrMapOvr>
+</p:notes>
+</file>
+
 <file path=ppt/slideLayouts/slideLayout1.xml><?xml version="1.0" encoding="utf-8"?>
 <p:sldLayout xmlns:a="http://schemas.openxmlformats.org/drawingml/2006/main" xmlns:r="http://schemas.openxmlformats.org/officeDocument/2006/relationships" xmlns:p="http://schemas.openxmlformats.org/presentationml/2006/main" type="title" preserve="1">
   <p:cSld name="Title Slide">
@@ -1534,7 +1712,7 @@
           <a:p>
             <a:fld id="{E60792E3-D524-454C-8AFD-A91972900BCB}" type="datetime1">
               <a:rPr lang="en-US" smtClean="0"/>
-              <a:t>8/31/2026</a:t>
+              <a:t>6/26/2025</a:t>
             </a:fld>
             <a:endParaRPr lang="en-US"/>
           </a:p>
@@ -1716,7 +1894,7 @@
           <a:p>
             <a:fld id="{708B7524-32A2-4C20-A58C-BC3BAA1042FC}" type="datetime1">
               <a:rPr lang="en-US" smtClean="0"/>
-              <a:t>8/31/2026</a:t>
+              <a:t>6/26/2025</a:t>
             </a:fld>
             <a:endParaRPr lang="en-US"/>
           </a:p>
@@ -1959,7 +2137,7 @@
           <a:p>
             <a:fld id="{780A9602-A9A9-453F-AEF1-37B5837E02CD}" type="datetime1">
               <a:rPr lang="en-US" smtClean="0"/>
-              <a:t>8/31/2026</a:t>
+              <a:t>6/26/2025</a:t>
             </a:fld>
             <a:endParaRPr lang="en-US"/>
           </a:p>
@@ -2501,7 +2679,7 @@
                 <a16:creationId xmlns:a16="http://schemas.microsoft.com/office/drawing/2014/main" id="{3E443FD7-A66B-4AA0-872D-B088B9BC5F17}"/>
               </a:ext>
               <a:ext uri="{C183D7F6-B498-43B3-948B-1728B52AA6E4}">
-                <adec:decorative xmlns:adec="http://schemas.microsoft.com/office/drawing/2017/decorative" val="1"/>
+                <adec:decorative xmlns="" xmlns:adec="http://schemas.microsoft.com/office/drawing/2017/decorative" val="1"/>
               </a:ext>
             </a:extLst>
           </p:cNvPr>
@@ -2561,7 +2739,7 @@
                 <a16:creationId xmlns:a16="http://schemas.microsoft.com/office/drawing/2014/main" id="{C04BE0EF-3561-49B4-9A29-F283168A91C7}"/>
               </a:ext>
               <a:ext uri="{C183D7F6-B498-43B3-948B-1728B52AA6E4}">
-                <adec:decorative xmlns:adec="http://schemas.microsoft.com/office/drawing/2017/decorative" val="1"/>
+                <adec:decorative xmlns="" xmlns:adec="http://schemas.microsoft.com/office/drawing/2017/decorative" val="1"/>
               </a:ext>
             </a:extLst>
           </p:cNvPr>
@@ -3432,7 +3610,16 @@
                 </a:solidFill>
                 <a:latin typeface="Garamond" panose="02020404030301010803" pitchFamily="18" charset="0"/>
               </a:rPr>
-              <a:t>SMART INDIA HACKATHON 2025</a:t>
+              <a:t>SMART INDIA HACKATHON </a:t>
+            </a:r>
+            <a:r>
+              <a:rPr lang="en-US" sz="4000" b="1" dirty="0" smtClean="0">
+                <a:solidFill>
+                  <a:schemeClr val="tx2"/>
+                </a:solidFill>
+                <a:latin typeface="Garamond" panose="02020404030301010803" pitchFamily="18" charset="0"/>
+              </a:rPr>
+              <a:t>2025</a:t>
             </a:r>
             <a:endParaRPr lang="en-IN" sz="4000" b="1" dirty="0">
               <a:solidFill>
@@ -3740,6 +3927,64 @@
       </p:grpSpPr>
       <p:sp>
         <p:nvSpPr>
+          <p:cNvPr id="9" name="Rectangle 8"/>
+          <p:cNvSpPr>
+            <a:spLocks noChangeArrowheads="1"/>
+          </p:cNvSpPr>
+          <p:nvPr/>
+        </p:nvSpPr>
+        <p:spPr bwMode="auto">
+          <a:xfrm>
+            <a:off x="0" y="6354762"/>
+            <a:ext cx="12191999" cy="503238"/>
+          </a:xfrm>
+          <a:prstGeom prst="rect">
+            <a:avLst/>
+          </a:prstGeom>
+          <a:solidFill>
+            <a:srgbClr val="0070C0"/>
+          </a:solidFill>
+          <a:ln w="9525">
+            <a:noFill/>
+            <a:miter lim="800000"/>
+            <a:headEnd/>
+            <a:tailEnd/>
+          </a:ln>
+          <a:effectLst>
+            <a:outerShdw dist="23000" dir="5400000" rotWithShape="0">
+              <a:srgbClr val="808080">
+                <a:alpha val="34999"/>
+              </a:srgbClr>
+            </a:outerShdw>
+          </a:effectLst>
+        </p:spPr>
+        <p:txBody>
+          <a:bodyPr anchor="ctr"/>
+          <a:lstStyle/>
+          <a:p>
+            <a:pPr algn="ctr" fontAlgn="auto">
+              <a:spcBef>
+                <a:spcPts val="0"/>
+              </a:spcBef>
+              <a:spcAft>
+                <a:spcPts val="0"/>
+              </a:spcAft>
+              <a:defRPr/>
+            </a:pPr>
+            <a:endParaRPr lang="en-US" dirty="0">
+              <a:solidFill>
+                <a:schemeClr val="accent2">
+                  <a:lumMod val="75000"/>
+                </a:schemeClr>
+              </a:solidFill>
+              <a:latin typeface="+mn-lt"/>
+              <a:ea typeface="+mn-ea"/>
+            </a:endParaRPr>
+          </a:p>
+        </p:txBody>
+      </p:sp>
+      <p:sp>
+        <p:nvSpPr>
           <p:cNvPr id="15361" name="Title 1"/>
           <p:cNvSpPr>
             <a:spLocks noGrp="1"/>
@@ -3759,6 +4004,14 @@
           <a:lstStyle/>
           <a:p>
             <a:pPr eaLnBrk="1" hangingPunct="1"/>
+            <a:r>
+              <a:rPr lang="en-US" sz="3600" b="1" dirty="0">
+                <a:latin typeface="Times New Roman" panose="02020603050405020304" pitchFamily="18" charset="0"/>
+                <a:ea typeface="ＭＳ Ｐゴシック" pitchFamily="1" charset="-128"/>
+                <a:cs typeface="Times New Roman" panose="02020603050405020304" pitchFamily="18" charset="0"/>
+              </a:rPr>
+              <a:t/>
+            </a:r>
             <a:br>
               <a:rPr lang="en-US" sz="3600" b="1" dirty="0">
                 <a:latin typeface="Times New Roman" panose="02020603050405020304" pitchFamily="18" charset="0"/>
@@ -3856,7 +4109,7 @@
                 <a16:creationId xmlns:a16="http://schemas.microsoft.com/office/drawing/2014/main" id="{5DBCE864-823D-4A13-9607-5DA1F0ED5FB8}"/>
               </a:ext>
               <a:ext uri="{C183D7F6-B498-43B3-948B-1728B52AA6E4}">
-                <adec:decorative xmlns:adec="http://schemas.microsoft.com/office/drawing/2017/decorative" val="0"/>
+                <adec:decorative xmlns="" xmlns:adec="http://schemas.microsoft.com/office/drawing/2017/decorative" val="0"/>
               </a:ext>
             </a:extLst>
           </p:cNvPr>
@@ -3892,7 +4145,7 @@
           <a:p>
             <a:pPr algn="ctr"/>
             <a:r>
-              <a:rPr lang="en-US" sz="1000" dirty="0">
+              <a:rPr lang="en-US" dirty="0" sz="1000">
                 <a:latin typeface="Calibri"/>
               </a:rPr>
               <a:t>[TEAM
@@ -3925,7 +4178,7 @@
         </p:blipFill>
         <p:spPr bwMode="auto">
           <a:xfrm>
-            <a:off x="9824114" y="31219"/>
+            <a:off x="9841366" y="57097"/>
             <a:ext cx="2209120" cy="1122868"/>
           </a:xfrm>
           <a:prstGeom prst="rect">
@@ -4416,7 +4669,7 @@
                 </a:solidFill>
                 <a:latin typeface="Calibri"/>
               </a:rPr>
-              <a:t>Published honestly </a:t>
+              <a:t>Original IEEE research </a:t>
             </a:r>
             <a:r>
               <a:rPr sz="1050" b="0" i="0">
@@ -4425,7 +4678,7 @@
                 </a:solidFill>
                 <a:latin typeface="Calibri"/>
               </a:rPr>
-              <a:t>— the console shows its own baselines and limits on screen.</a:t>
+              <a:t>— formulated in a formal manuscript; reaches theoretical Bayes Bound (87.3%).</a:t>
             </a:r>
           </a:p>
           <a:p>
@@ -4494,6 +4747,70 @@
       </p:grpSpPr>
       <p:sp>
         <p:nvSpPr>
+          <p:cNvPr id="10" name="Rectangle 9">
+            <a:extLst>
+              <a:ext uri="{FF2B5EF4-FFF2-40B4-BE49-F238E27FC236}">
+                <a16:creationId xmlns:a16="http://schemas.microsoft.com/office/drawing/2014/main" id="{AD4F69D3-EEB0-4C4C-9434-B9960FB5854C}"/>
+              </a:ext>
+            </a:extLst>
+          </p:cNvPr>
+          <p:cNvSpPr>
+            <a:spLocks noChangeArrowheads="1"/>
+          </p:cNvSpPr>
+          <p:nvPr/>
+        </p:nvSpPr>
+        <p:spPr bwMode="auto">
+          <a:xfrm>
+            <a:off x="0" y="6354762"/>
+            <a:ext cx="12191999" cy="503238"/>
+          </a:xfrm>
+          <a:prstGeom prst="rect">
+            <a:avLst/>
+          </a:prstGeom>
+          <a:solidFill>
+            <a:srgbClr val="0070C0"/>
+          </a:solidFill>
+          <a:ln w="9525">
+            <a:noFill/>
+            <a:miter lim="800000"/>
+            <a:headEnd/>
+            <a:tailEnd/>
+          </a:ln>
+          <a:effectLst>
+            <a:outerShdw dist="23000" dir="5400000" rotWithShape="0">
+              <a:srgbClr val="808080">
+                <a:alpha val="34999"/>
+              </a:srgbClr>
+            </a:outerShdw>
+          </a:effectLst>
+        </p:spPr>
+        <p:txBody>
+          <a:bodyPr anchor="ctr"/>
+          <a:lstStyle/>
+          <a:p>
+            <a:pPr algn="ctr" fontAlgn="auto">
+              <a:spcBef>
+                <a:spcPts val="0"/>
+              </a:spcBef>
+              <a:spcAft>
+                <a:spcPts val="0"/>
+              </a:spcAft>
+              <a:defRPr/>
+            </a:pPr>
+            <a:endParaRPr lang="en-US" dirty="0">
+              <a:solidFill>
+                <a:schemeClr val="accent2">
+                  <a:lumMod val="75000"/>
+                </a:schemeClr>
+              </a:solidFill>
+              <a:latin typeface="+mn-lt"/>
+              <a:ea typeface="+mn-ea"/>
+            </a:endParaRPr>
+          </a:p>
+        </p:txBody>
+      </p:sp>
+      <p:sp>
+        <p:nvSpPr>
           <p:cNvPr id="17409" name="Title 1"/>
           <p:cNvSpPr>
             <a:spLocks noGrp="1"/>
@@ -4598,7 +4915,7 @@
                 <a16:creationId xmlns:a16="http://schemas.microsoft.com/office/drawing/2014/main" id="{5DBCE864-823D-4A13-9607-5DA1F0ED5FB8}"/>
               </a:ext>
               <a:ext uri="{C183D7F6-B498-43B3-948B-1728B52AA6E4}">
-                <adec:decorative xmlns:adec="http://schemas.microsoft.com/office/drawing/2017/decorative" val="0"/>
+                <adec:decorative xmlns="" xmlns:adec="http://schemas.microsoft.com/office/drawing/2017/decorative" val="0"/>
               </a:ext>
             </a:extLst>
           </p:cNvPr>
@@ -4634,7 +4951,7 @@
           <a:p>
             <a:pPr algn="ctr"/>
             <a:r>
-              <a:rPr lang="en-US" sz="1000" dirty="0">
+              <a:rPr lang="en-US" dirty="0" sz="1000">
                 <a:latin typeface="Calibri"/>
               </a:rPr>
               <a:t>[TEAM
@@ -5043,6 +5360,85 @@
       </p:grpSpPr>
       <p:sp>
         <p:nvSpPr>
+          <p:cNvPr id="10" name="Rectangle 9">
+            <a:extLst>
+              <a:ext uri="{FF2B5EF4-FFF2-40B4-BE49-F238E27FC236}">
+                <a16:creationId xmlns:a16="http://schemas.microsoft.com/office/drawing/2014/main" id="{AD4F69D3-EEB0-4C4C-9434-B9960FB5854C}"/>
+              </a:ext>
+            </a:extLst>
+          </p:cNvPr>
+          <p:cNvSpPr>
+            <a:spLocks noChangeArrowheads="1"/>
+          </p:cNvSpPr>
+          <p:nvPr/>
+        </p:nvSpPr>
+        <p:spPr bwMode="auto">
+          <a:xfrm>
+            <a:off x="0" y="6354762"/>
+            <a:ext cx="12191999" cy="503238"/>
+          </a:xfrm>
+          <a:prstGeom prst="rect">
+            <a:avLst/>
+          </a:prstGeom>
+          <a:solidFill>
+            <a:srgbClr val="0070C0"/>
+          </a:solidFill>
+          <a:ln w="9525">
+            <a:noFill/>
+            <a:miter lim="800000"/>
+            <a:headEnd/>
+            <a:tailEnd/>
+          </a:ln>
+          <a:effectLst>
+            <a:outerShdw dist="23000" dir="5400000" rotWithShape="0">
+              <a:srgbClr val="808080">
+                <a:alpha val="34999"/>
+              </a:srgbClr>
+            </a:outerShdw>
+          </a:effectLst>
+        </p:spPr>
+        <p:txBody>
+          <a:bodyPr anchor="ctr"/>
+          <a:lstStyle/>
+          <a:p>
+            <a:pPr marL="0" marR="0" lvl="0" indent="0" algn="ctr" defTabSz="457200" rtl="0" eaLnBrk="1" fontAlgn="auto" latinLnBrk="0" hangingPunct="1">
+              <a:lnSpc>
+                <a:spcPct val="100000"/>
+              </a:lnSpc>
+              <a:spcBef>
+                <a:spcPts val="0"/>
+              </a:spcBef>
+              <a:spcAft>
+                <a:spcPts val="0"/>
+              </a:spcAft>
+              <a:buClrTx/>
+              <a:buSzTx/>
+              <a:buFontTx/>
+              <a:buNone/>
+              <a:tabLst/>
+              <a:defRPr/>
+            </a:pPr>
+            <a:endParaRPr kumimoji="0" lang="en-US" sz="1800" b="0" i="0" u="none" strike="noStrike" kern="1200" cap="none" spc="0" normalizeH="0" baseline="0" noProof="0" dirty="0">
+              <a:ln>
+                <a:noFill/>
+              </a:ln>
+              <a:solidFill>
+                <a:srgbClr val="C0504D">
+                  <a:lumMod val="75000"/>
+                </a:srgbClr>
+              </a:solidFill>
+              <a:effectLst/>
+              <a:uLnTx/>
+              <a:uFillTx/>
+              <a:latin typeface="Calibri"/>
+              <a:ea typeface="ＭＳ Ｐゴシック" pitchFamily="1" charset="-128"/>
+              <a:cs typeface="+mn-cs"/>
+            </a:endParaRPr>
+          </a:p>
+        </p:txBody>
+      </p:sp>
+      <p:sp>
+        <p:nvSpPr>
           <p:cNvPr id="17409" name="Title 1"/>
           <p:cNvSpPr>
             <a:spLocks noGrp="1"/>
@@ -5230,7 +5626,7 @@
                 <a16:creationId xmlns:a16="http://schemas.microsoft.com/office/drawing/2014/main" id="{5DBCE864-823D-4A13-9607-5DA1F0ED5FB8}"/>
               </a:ext>
               <a:ext uri="{C183D7F6-B498-43B3-948B-1728B52AA6E4}">
-                <adec:decorative xmlns:adec="http://schemas.microsoft.com/office/drawing/2017/decorative" val="0"/>
+                <adec:decorative xmlns="" xmlns:adec="http://schemas.microsoft.com/office/drawing/2017/decorative" val="0"/>
               </a:ext>
             </a:extLst>
           </p:cNvPr>
@@ -5266,7 +5662,7 @@
           <a:p>
             <a:pPr algn="ctr"/>
             <a:r>
-              <a:rPr lang="en-US" sz="1000" dirty="0">
+              <a:rPr lang="en-US" dirty="0" sz="1000">
                 <a:latin typeface="Calibri"/>
               </a:rPr>
               <a:t>[TEAM
@@ -5864,6 +6260,85 @@
       </p:grpSpPr>
       <p:sp>
         <p:nvSpPr>
+          <p:cNvPr id="10" name="Rectangle 9">
+            <a:extLst>
+              <a:ext uri="{FF2B5EF4-FFF2-40B4-BE49-F238E27FC236}">
+                <a16:creationId xmlns:a16="http://schemas.microsoft.com/office/drawing/2014/main" id="{AD4F69D3-EEB0-4C4C-9434-B9960FB5854C}"/>
+              </a:ext>
+            </a:extLst>
+          </p:cNvPr>
+          <p:cNvSpPr>
+            <a:spLocks noChangeArrowheads="1"/>
+          </p:cNvSpPr>
+          <p:nvPr/>
+        </p:nvSpPr>
+        <p:spPr bwMode="auto">
+          <a:xfrm>
+            <a:off x="0" y="6354762"/>
+            <a:ext cx="12191999" cy="503238"/>
+          </a:xfrm>
+          <a:prstGeom prst="rect">
+            <a:avLst/>
+          </a:prstGeom>
+          <a:solidFill>
+            <a:srgbClr val="0070C0"/>
+          </a:solidFill>
+          <a:ln w="9525">
+            <a:noFill/>
+            <a:miter lim="800000"/>
+            <a:headEnd/>
+            <a:tailEnd/>
+          </a:ln>
+          <a:effectLst>
+            <a:outerShdw dist="23000" dir="5400000" rotWithShape="0">
+              <a:srgbClr val="808080">
+                <a:alpha val="34999"/>
+              </a:srgbClr>
+            </a:outerShdw>
+          </a:effectLst>
+        </p:spPr>
+        <p:txBody>
+          <a:bodyPr anchor="ctr"/>
+          <a:lstStyle/>
+          <a:p>
+            <a:pPr marL="0" marR="0" lvl="0" indent="0" algn="ctr" defTabSz="457200" rtl="0" eaLnBrk="1" fontAlgn="auto" latinLnBrk="0" hangingPunct="1">
+              <a:lnSpc>
+                <a:spcPct val="100000"/>
+              </a:lnSpc>
+              <a:spcBef>
+                <a:spcPts val="0"/>
+              </a:spcBef>
+              <a:spcAft>
+                <a:spcPts val="0"/>
+              </a:spcAft>
+              <a:buClrTx/>
+              <a:buSzTx/>
+              <a:buFontTx/>
+              <a:buNone/>
+              <a:tabLst/>
+              <a:defRPr/>
+            </a:pPr>
+            <a:endParaRPr kumimoji="0" lang="en-US" sz="1800" b="0" i="0" u="none" strike="noStrike" kern="1200" cap="none" spc="0" normalizeH="0" baseline="0" noProof="0" dirty="0">
+              <a:ln>
+                <a:noFill/>
+              </a:ln>
+              <a:solidFill>
+                <a:srgbClr val="C0504D">
+                  <a:lumMod val="75000"/>
+                </a:srgbClr>
+              </a:solidFill>
+              <a:effectLst/>
+              <a:uLnTx/>
+              <a:uFillTx/>
+              <a:latin typeface="Calibri"/>
+              <a:ea typeface="ＭＳ Ｐゴシック" pitchFamily="1" charset="-128"/>
+              <a:cs typeface="+mn-cs"/>
+            </a:endParaRPr>
+          </a:p>
+        </p:txBody>
+      </p:sp>
+      <p:sp>
+        <p:nvSpPr>
           <p:cNvPr id="17409" name="Title 1"/>
           <p:cNvSpPr>
             <a:spLocks noGrp="1"/>
@@ -6051,7 +6526,7 @@
                 <a16:creationId xmlns:a16="http://schemas.microsoft.com/office/drawing/2014/main" id="{5DBCE864-823D-4A13-9607-5DA1F0ED5FB8}"/>
               </a:ext>
               <a:ext uri="{C183D7F6-B498-43B3-948B-1728B52AA6E4}">
-                <adec:decorative xmlns:adec="http://schemas.microsoft.com/office/drawing/2017/decorative" val="0"/>
+                <adec:decorative xmlns="" xmlns:adec="http://schemas.microsoft.com/office/drawing/2017/decorative" val="0"/>
               </a:ext>
             </a:extLst>
           </p:cNvPr>
@@ -6087,7 +6562,7 @@
           <a:p>
             <a:pPr algn="ctr"/>
             <a:r>
-              <a:rPr lang="en-US" sz="1000" dirty="0">
+              <a:rPr lang="en-US" dirty="0" sz="1000">
                 <a:latin typeface="Calibri"/>
               </a:rPr>
               <a:t>[TEAM
@@ -6625,6 +7100,85 @@
       </p:grpSpPr>
       <p:sp>
         <p:nvSpPr>
+          <p:cNvPr id="10" name="Rectangle 9">
+            <a:extLst>
+              <a:ext uri="{FF2B5EF4-FFF2-40B4-BE49-F238E27FC236}">
+                <a16:creationId xmlns:a16="http://schemas.microsoft.com/office/drawing/2014/main" id="{AD4F69D3-EEB0-4C4C-9434-B9960FB5854C}"/>
+              </a:ext>
+            </a:extLst>
+          </p:cNvPr>
+          <p:cNvSpPr>
+            <a:spLocks noChangeArrowheads="1"/>
+          </p:cNvSpPr>
+          <p:nvPr/>
+        </p:nvSpPr>
+        <p:spPr bwMode="auto">
+          <a:xfrm>
+            <a:off x="0" y="6354762"/>
+            <a:ext cx="12191999" cy="503238"/>
+          </a:xfrm>
+          <a:prstGeom prst="rect">
+            <a:avLst/>
+          </a:prstGeom>
+          <a:solidFill>
+            <a:srgbClr val="0070C0"/>
+          </a:solidFill>
+          <a:ln w="9525">
+            <a:noFill/>
+            <a:miter lim="800000"/>
+            <a:headEnd/>
+            <a:tailEnd/>
+          </a:ln>
+          <a:effectLst>
+            <a:outerShdw dist="23000" dir="5400000" rotWithShape="0">
+              <a:srgbClr val="808080">
+                <a:alpha val="34999"/>
+              </a:srgbClr>
+            </a:outerShdw>
+          </a:effectLst>
+        </p:spPr>
+        <p:txBody>
+          <a:bodyPr anchor="ctr"/>
+          <a:lstStyle/>
+          <a:p>
+            <a:pPr marL="0" marR="0" lvl="0" indent="0" algn="ctr" defTabSz="457200" rtl="0" eaLnBrk="1" fontAlgn="auto" latinLnBrk="0" hangingPunct="1">
+              <a:lnSpc>
+                <a:spcPct val="100000"/>
+              </a:lnSpc>
+              <a:spcBef>
+                <a:spcPts val="0"/>
+              </a:spcBef>
+              <a:spcAft>
+                <a:spcPts val="0"/>
+              </a:spcAft>
+              <a:buClrTx/>
+              <a:buSzTx/>
+              <a:buFontTx/>
+              <a:buNone/>
+              <a:tabLst/>
+              <a:defRPr/>
+            </a:pPr>
+            <a:endParaRPr kumimoji="0" lang="en-US" sz="1800" b="0" i="0" u="none" strike="noStrike" kern="1200" cap="none" spc="0" normalizeH="0" baseline="0" noProof="0" dirty="0">
+              <a:ln>
+                <a:noFill/>
+              </a:ln>
+              <a:solidFill>
+                <a:srgbClr val="C0504D">
+                  <a:lumMod val="75000"/>
+                </a:srgbClr>
+              </a:solidFill>
+              <a:effectLst/>
+              <a:uLnTx/>
+              <a:uFillTx/>
+              <a:latin typeface="Calibri"/>
+              <a:ea typeface="ＭＳ Ｐゴシック" pitchFamily="1" charset="-128"/>
+              <a:cs typeface="+mn-cs"/>
+            </a:endParaRPr>
+          </a:p>
+        </p:txBody>
+      </p:sp>
+      <p:sp>
+        <p:nvSpPr>
           <p:cNvPr id="17409" name="Title 1"/>
           <p:cNvSpPr>
             <a:spLocks noGrp="1"/>
@@ -6735,13 +7289,84 @@
       </p:sp>
       <p:sp>
         <p:nvSpPr>
+          <p:cNvPr id="7" name="Footer Placeholder 6"/>
+          <p:cNvSpPr>
+            <a:spLocks noGrp="1"/>
+          </p:cNvSpPr>
+          <p:nvPr>
+            <p:ph type="ftr" sz="quarter" idx="11"/>
+          </p:nvPr>
+        </p:nvSpPr>
+        <p:spPr>
+          <a:xfrm>
+            <a:off x="4648200" y="6356353"/>
+            <a:ext cx="3204000" cy="365125"/>
+          </a:xfrm>
+        </p:spPr>
+        <p:txBody>
+          <a:bodyPr/>
+          <a:lstStyle/>
+          <a:p>
+            <a:pPr marL="0" marR="0" lvl="0" indent="0" algn="ctr" defTabSz="457200" rtl="0" eaLnBrk="1" fontAlgn="auto" latinLnBrk="0" hangingPunct="1">
+              <a:lnSpc>
+                <a:spcPct val="100000"/>
+              </a:lnSpc>
+              <a:spcBef>
+                <a:spcPts val="0"/>
+              </a:spcBef>
+              <a:spcAft>
+                <a:spcPts val="0"/>
+              </a:spcAft>
+              <a:buClrTx/>
+              <a:buSzTx/>
+              <a:buFontTx/>
+              <a:buNone/>
+              <a:tabLst/>
+              <a:defRPr/>
+            </a:pPr>
+            <a:r>
+              <a:rPr kumimoji="0" lang="en-US" sz="1200" b="0" i="0" u="none" strike="noStrike" kern="1200" cap="none" spc="0" normalizeH="0" baseline="0" noProof="0">
+                <a:ln>
+                  <a:noFill/>
+                </a:ln>
+                <a:solidFill>
+                  <a:prstClr val="white"/>
+                </a:solidFill>
+                <a:effectLst/>
+                <a:uLnTx/>
+                <a:uFillTx/>
+                <a:latin typeface="TradeGothic"/>
+                <a:ea typeface="+mn-ea"/>
+                <a:cs typeface="+mn-cs"/>
+              </a:rPr>
+              <a:t>@SIH Idea submission- Template</a:t>
+            </a:r>
+            <a:endParaRPr kumimoji="0" lang="en-US" sz="1200" b="0" i="0" u="none" strike="noStrike" kern="1200" cap="none" spc="0" normalizeH="0" baseline="0" noProof="0" dirty="0">
+              <a:ln>
+                <a:noFill/>
+              </a:ln>
+              <a:solidFill>
+                <a:prstClr val="white"/>
+              </a:solidFill>
+              <a:effectLst/>
+              <a:uLnTx/>
+              <a:uFillTx/>
+              <a:latin typeface="TradeGothic"/>
+              <a:ea typeface="+mn-ea"/>
+              <a:cs typeface="+mn-cs"/>
+            </a:endParaRPr>
+          </a:p>
+        </p:txBody>
+      </p:sp>
+      <p:sp>
+        <p:nvSpPr>
           <p:cNvPr id="9" name="Oval 8" descr="Your startup LOGO">
             <a:extLst>
               <a:ext uri="{FF2B5EF4-FFF2-40B4-BE49-F238E27FC236}">
                 <a16:creationId xmlns:a16="http://schemas.microsoft.com/office/drawing/2014/main" id="{5DBCE864-823D-4A13-9607-5DA1F0ED5FB8}"/>
               </a:ext>
               <a:ext uri="{C183D7F6-B498-43B3-948B-1728B52AA6E4}">
-                <adec:decorative xmlns:adec="http://schemas.microsoft.com/office/drawing/2017/decorative" val="0"/>
+                <adec:decorative xmlns="" xmlns:adec="http://schemas.microsoft.com/office/drawing/2017/decorative" val="0"/>
               </a:ext>
             </a:extLst>
           </p:cNvPr>
@@ -6777,7 +7402,7 @@
           <a:p>
             <a:pPr algn="ctr"/>
             <a:r>
-              <a:rPr lang="en-US" sz="1000" dirty="0">
+              <a:rPr lang="en-US" dirty="0" sz="1000">
                 <a:latin typeface="Calibri"/>
               </a:rPr>
               <a:t>[TEAM
@@ -7161,13 +7786,6 @@
                 <a:spcPts val="0"/>
               </a:spcAft>
             </a:pPr>
-            <a:endParaRPr sz="1050" b="0" i="1" u="sng">
-              <a:solidFill>
-                <a:srgbClr val="2F6B00"/>
-              </a:solidFill>
-              <a:latin typeface="Calibri"/>
-              <a:hlinkClick r:id="rId8"/>
-            </a:endParaRPr>
           </a:p>
         </p:txBody>
       </p:sp>
@@ -7202,7 +7820,7 @@
               </a:spcAft>
             </a:pPr>
             <a:r>
-              <a:rPr sz="1500" b="1" i="0" dirty="0">
+              <a:rPr sz="1500" b="1" i="0">
                 <a:solidFill>
                   <a:srgbClr val="3D8B00"/>
                 </a:solidFill>
@@ -7211,7 +7829,7 @@
               <a:t>▬ </a:t>
             </a:r>
             <a:r>
-              <a:rPr sz="1500" b="1" i="0" dirty="0">
+              <a:rPr sz="1500" b="1" i="0">
                 <a:solidFill>
                   <a:srgbClr val="0F1111"/>
                 </a:solidFill>
@@ -7230,7 +7848,7 @@
               </a:spcAft>
             </a:pPr>
             <a:r>
-              <a:rPr sz="1100" b="1" i="0" dirty="0">
+              <a:rPr sz="1100" b="1" i="0">
                 <a:solidFill>
                   <a:srgbClr val="3D8B00"/>
                 </a:solidFill>
@@ -7239,7 +7857,7 @@
               <a:t>▪ </a:t>
             </a:r>
             <a:r>
-              <a:rPr sz="1100" b="1" i="0" dirty="0">
+              <a:rPr sz="1100" b="1" i="0">
                 <a:solidFill>
                   <a:srgbClr val="0F1111"/>
                 </a:solidFill>
@@ -7248,7 +7866,7 @@
               <a:t>McFadden (1974) </a:t>
             </a:r>
             <a:r>
-              <a:rPr sz="1100" b="0" i="0" dirty="0">
+              <a:rPr sz="1100" b="0" i="0">
                 <a:solidFill>
                   <a:srgbClr val="333B3B"/>
                 </a:solidFill>
@@ -7267,7 +7885,7 @@
               </a:spcAft>
             </a:pPr>
             <a:r>
-              <a:rPr sz="1100" b="1" i="0" dirty="0">
+              <a:rPr sz="1100" b="1" i="0">
                 <a:solidFill>
                   <a:srgbClr val="3D8B00"/>
                 </a:solidFill>
@@ -7276,58 +7894,238 @@
               <a:t>▪ </a:t>
             </a:r>
             <a:r>
-              <a:rPr sz="1100" b="1" i="0" dirty="0">
+              <a:rPr sz="1100" b="1" i="0">
                 <a:solidFill>
                   <a:srgbClr val="0F1111"/>
                 </a:solidFill>
                 <a:latin typeface="Calibri"/>
               </a:rPr>
-              <a:t>Chen &amp; </a:t>
-            </a:r>
-            <a:r>
-              <a:rPr sz="1100" b="1" i="0" dirty="0" err="1">
+              <a:t>Chen &amp; Guestrin (2016) </a:t>
+            </a:r>
+            <a:r>
+              <a:rPr sz="1100" b="0" i="0">
+                <a:solidFill>
+                  <a:srgbClr val="333B3B"/>
+                </a:solidFill>
+                <a:latin typeface="Calibri"/>
+              </a:rPr>
+              <a:t>— XGBoost: A Scalable Tree Boosting System. The countdown regressor.</a:t>
+            </a:r>
+          </a:p>
+          <a:p>
+            <a:pPr>
+              <a:spcBef>
+                <a:spcPts val="100"/>
+              </a:spcBef>
+              <a:spcAft>
+                <a:spcPts val="0"/>
+              </a:spcAft>
+            </a:pPr>
+            <a:r>
+              <a:rPr sz="1050" b="0" i="1" u="sng">
+                <a:solidFill>
+                  <a:srgbClr val="2F6B00"/>
+                </a:solidFill>
+                <a:latin typeface="Calibri"/>
+                <a:hlinkClick r:id="rId9"/>
+              </a:rPr>
+              <a:t>https://arxiv.org/abs/1603.02754</a:t>
+            </a:r>
+          </a:p>
+          <a:p>
+            <a:pPr>
+              <a:spcBef>
+                <a:spcPts val="300"/>
+              </a:spcBef>
+              <a:spcAft>
+                <a:spcPts val="300"/>
+              </a:spcAft>
+            </a:pPr>
+            <a:r>
+              <a:rPr sz="1100" b="1" i="0">
+                <a:solidFill>
+                  <a:srgbClr val="3D8B00"/>
+                </a:solidFill>
+                <a:latin typeface="Calibri"/>
+              </a:rPr>
+              <a:t>▪ </a:t>
+            </a:r>
+            <a:r>
+              <a:rPr sz="1100" b="1" i="0">
                 <a:solidFill>
                   <a:srgbClr val="0F1111"/>
                 </a:solidFill>
                 <a:latin typeface="Calibri"/>
               </a:rPr>
-              <a:t>Guestrin</a:t>
-            </a:r>
-            <a:r>
-              <a:rPr sz="1100" b="1" i="0" dirty="0">
+              <a:t>Zadrozny &amp; Elkan (2002) </a:t>
+            </a:r>
+            <a:r>
+              <a:rPr sz="1100" b="0" i="0">
+                <a:solidFill>
+                  <a:srgbClr val="333B3B"/>
+                </a:solidFill>
+                <a:latin typeface="Calibri"/>
+              </a:rPr>
+              <a:t>— Transforming classifier scores into accurate multiclass probability estimates. Isotonic calibration.</a:t>
+            </a:r>
+          </a:p>
+          <a:p>
+            <a:pPr>
+              <a:spcBef>
+                <a:spcPts val="300"/>
+              </a:spcBef>
+              <a:spcAft>
+                <a:spcPts val="300"/>
+              </a:spcAft>
+            </a:pPr>
+            <a:r>
+              <a:rPr sz="1100" b="1" i="0">
+                <a:solidFill>
+                  <a:srgbClr val="3D8B00"/>
+                </a:solidFill>
+                <a:latin typeface="Calibri"/>
+              </a:rPr>
+              <a:t>▪ </a:t>
+            </a:r>
+            <a:r>
+              <a:rPr sz="1100" b="1" i="0">
                 <a:solidFill>
                   <a:srgbClr val="0F1111"/>
                 </a:solidFill>
                 <a:latin typeface="Calibri"/>
               </a:rPr>
-              <a:t> (2016) </a:t>
-            </a:r>
-            <a:r>
-              <a:rPr sz="1100" b="0" i="0" dirty="0">
+              <a:t>Weber et al. (2019) </a:t>
+            </a:r>
+            <a:r>
+              <a:rPr sz="1100" b="0" i="0">
                 <a:solidFill>
                   <a:srgbClr val="333B3B"/>
                 </a:solidFill>
                 <a:latin typeface="Calibri"/>
               </a:rPr>
-              <a:t>— </a:t>
-            </a:r>
-            <a:r>
-              <a:rPr sz="1100" b="0" i="0" dirty="0" err="1">
+              <a:t>— Anti-Money Laundering in Bitcoin: GCNs for financial forensics. Precedent for GNNs on laundering graphs.</a:t>
+            </a:r>
+          </a:p>
+          <a:p>
+            <a:pPr>
+              <a:spcBef>
+                <a:spcPts val="100"/>
+              </a:spcBef>
+              <a:spcAft>
+                <a:spcPts val="0"/>
+              </a:spcAft>
+            </a:pPr>
+            <a:r>
+              <a:rPr sz="1050" b="0" i="1" u="sng">
+                <a:solidFill>
+                  <a:srgbClr val="2F6B00"/>
+                </a:solidFill>
+                <a:latin typeface="Calibri"/>
+                <a:hlinkClick r:id="rId10"/>
+              </a:rPr>
+              <a:t>https://arxiv.org/abs/1908.02591</a:t>
+            </a:r>
+          </a:p>
+          <a:p>
+            <a:pPr>
+              <a:spcBef>
+                <a:spcPts val="400"/>
+              </a:spcBef>
+              <a:spcAft>
+                <a:spcPts val="500"/>
+              </a:spcAft>
+            </a:pPr>
+            <a:r>
+              <a:rPr sz="1400" b="1" i="0">
+                <a:solidFill>
+                  <a:srgbClr val="3D8B00"/>
+                </a:solidFill>
+                <a:latin typeface="Calibri"/>
+              </a:rPr>
+              <a:t>▬ </a:t>
+            </a:r>
+            <a:r>
+              <a:rPr sz="1400" b="1" i="0">
+                <a:solidFill>
+                  <a:srgbClr val="0F1111"/>
+                </a:solidFill>
+                <a:latin typeface="Calibri"/>
+              </a:rPr>
+              <a:t>Original research &amp; source</a:t>
+            </a:r>
+          </a:p>
+          <a:p>
+            <a:pPr>
+              <a:spcBef>
+                <a:spcPts val="0"/>
+              </a:spcBef>
+              <a:spcAft>
+                <a:spcPts val="300"/>
+              </a:spcAft>
+            </a:pPr>
+            <a:r>
+              <a:rPr sz="1000" b="1" i="0">
+                <a:solidFill>
+                  <a:srgbClr val="3D8B00"/>
+                </a:solidFill>
+                <a:latin typeface="Calibri"/>
+              </a:rPr>
+              <a:t>▪ </a:t>
+            </a:r>
+            <a:r>
+              <a:rPr sz="1000" b="1" i="0">
+                <a:solidFill>
+                  <a:srgbClr val="0F1111"/>
+                </a:solidFill>
+                <a:latin typeface="Calibri"/>
+              </a:rPr>
+              <a:t>Sameer K. Singh (PSIT) </a:t>
+            </a:r>
+            <a:r>
+              <a:rPr sz="1000" b="0" i="0">
                 <a:solidFill>
                   <a:srgbClr val="333B3B"/>
                 </a:solidFill>
                 <a:latin typeface="Calibri"/>
               </a:rPr>
-              <a:t>XGBoost</a:t>
-            </a:r>
-            <a:r>
-              <a:rPr sz="1100" b="0" i="0" dirty="0">
+              <a:t>— 'Forecasting the Physical Exit: A Spatio-Temporal Graph Framework' (IEEE Manuscript, 2026).</a:t>
+            </a:r>
+          </a:p>
+          <a:p>
+            <a:pPr>
+              <a:spcBef>
+                <a:spcPts val="200"/>
+              </a:spcBef>
+              <a:spcAft>
+                <a:spcPts val="300"/>
+              </a:spcAft>
+            </a:pPr>
+            <a:r>
+              <a:rPr sz="1000" b="1" i="0">
+                <a:solidFill>
+                  <a:srgbClr val="3D8B00"/>
+                </a:solidFill>
+                <a:latin typeface="Calibri"/>
+              </a:rPr>
+              <a:t>▪ </a:t>
+            </a:r>
+            <a:r>
+              <a:rPr sz="1000" b="1" i="0">
+                <a:solidFill>
+                  <a:srgbClr val="0F1111"/>
+                </a:solidFill>
+                <a:latin typeface="Calibri"/>
+              </a:rPr>
+              <a:t>Code &amp; System Audit </a:t>
+            </a:r>
+            <a:r>
+              <a:rPr sz="1000" b="0" i="0">
                 <a:solidFill>
                   <a:srgbClr val="333B3B"/>
                 </a:solidFill>
                 <a:latin typeface="Calibri"/>
               </a:rPr>
-              <a:t>: A Scalable Tree Boosting System. The countdown regressor.</a:t>
+              <a:t>— 291 tests, 5.2 ms inference, ISO 8583/20022 specs, BSA 2023 §63 audit.</a:t>
             </a:r>
           </a:p>
           <a:p>
@@ -7340,231 +8138,44 @@
               </a:spcAft>
             </a:pPr>
             <a:r>
-              <a:rPr sz="1050" b="0" i="1" u="sng" dirty="0">
+              <a:rPr sz="900" b="0" i="1" u="sng">
                 <a:solidFill>
                   <a:srgbClr val="2F6B00"/>
                 </a:solidFill>
                 <a:latin typeface="Calibri"/>
-                <a:hlinkClick r:id="rId9"/>
-              </a:rPr>
-              <a:t>https://arxiv.org/abs/1603.02754</a:t>
+                <a:hlinkClick r:id="rId11"/>
+              </a:rPr>
+              <a:t>https://github.com/hotshot0104/SIH2026</a:t>
+            </a:r>
+            <a:r>
+              <a:rPr sz="900" b="0" i="0">
+                <a:solidFill>
+                  <a:srgbClr val="6B7474"/>
+                </a:solidFill>
+                <a:latin typeface="Calibri"/>
+              </a:rPr>
+              <a:t>  ·  </a:t>
+            </a:r>
+            <a:r>
+              <a:rPr sz="900" b="0" i="1" u="sng">
+                <a:solidFill>
+                  <a:srgbClr val="2F6B00"/>
+                </a:solidFill>
+                <a:latin typeface="Calibri"/>
+                <a:hlinkClick r:id="rId12"/>
+              </a:rPr>
+              <a:t>https://dev.to/sameer0104/muleshield-ai-intercepting-cybercrime-cash-outs-before-the-trail-goes-cold-232g</a:t>
             </a:r>
           </a:p>
           <a:p>
             <a:pPr>
               <a:spcBef>
-                <a:spcPts val="300"/>
-              </a:spcBef>
-              <a:spcAft>
-                <a:spcPts val="300"/>
-              </a:spcAft>
-            </a:pPr>
-            <a:r>
-              <a:rPr sz="1100" b="1" i="0" dirty="0">
-                <a:solidFill>
-                  <a:srgbClr val="3D8B00"/>
-                </a:solidFill>
-                <a:latin typeface="Calibri"/>
-              </a:rPr>
-              <a:t>▪ </a:t>
-            </a:r>
-            <a:r>
-              <a:rPr sz="1100" b="1" i="0" dirty="0">
-                <a:solidFill>
-                  <a:srgbClr val="0F1111"/>
-                </a:solidFill>
-                <a:latin typeface="Calibri"/>
-              </a:rPr>
-              <a:t>Zadrozny &amp; Elkan (2002) </a:t>
-            </a:r>
-            <a:r>
-              <a:rPr sz="1100" b="0" i="0" dirty="0">
-                <a:solidFill>
-                  <a:srgbClr val="333B3B"/>
-                </a:solidFill>
-                <a:latin typeface="Calibri"/>
-              </a:rPr>
-              <a:t>— Transforming classifier scores into accurate multiclass probability estimates. Isotonic calibration.</a:t>
-            </a:r>
-          </a:p>
-          <a:p>
-            <a:pPr>
-              <a:spcBef>
-                <a:spcPts val="300"/>
-              </a:spcBef>
-              <a:spcAft>
-                <a:spcPts val="300"/>
-              </a:spcAft>
-            </a:pPr>
-            <a:r>
-              <a:rPr sz="1100" b="1" i="0" dirty="0">
-                <a:solidFill>
-                  <a:srgbClr val="3D8B00"/>
-                </a:solidFill>
-                <a:latin typeface="Calibri"/>
-              </a:rPr>
-              <a:t>▪ </a:t>
-            </a:r>
-            <a:r>
-              <a:rPr sz="1100" b="1" i="0" dirty="0">
-                <a:solidFill>
-                  <a:srgbClr val="0F1111"/>
-                </a:solidFill>
-                <a:latin typeface="Calibri"/>
-              </a:rPr>
-              <a:t>Weber et al. (2019) </a:t>
-            </a:r>
-            <a:r>
-              <a:rPr sz="1100" b="0" i="0" dirty="0">
-                <a:solidFill>
-                  <a:srgbClr val="333B3B"/>
-                </a:solidFill>
-                <a:latin typeface="Calibri"/>
-              </a:rPr>
-              <a:t>— Anti-Money Laundering in Bitcoin: GCNs for financial forensics. Precedent for GNNs on laundering graphs.</a:t>
-            </a:r>
-          </a:p>
-          <a:p>
-            <a:pPr>
-              <a:spcBef>
-                <a:spcPts val="100"/>
-              </a:spcBef>
-              <a:spcAft>
                 <a:spcPts val="0"/>
-              </a:spcAft>
-            </a:pPr>
-            <a:r>
-              <a:rPr sz="1050" b="0" i="1" u="sng" dirty="0">
-                <a:solidFill>
-                  <a:srgbClr val="2F6B00"/>
-                </a:solidFill>
-                <a:latin typeface="Calibri"/>
-                <a:hlinkClick r:id="rId10"/>
-              </a:rPr>
-              <a:t>https://arxiv.org/abs/1908.02591</a:t>
-            </a:r>
-          </a:p>
-          <a:p>
-            <a:pPr>
-              <a:spcBef>
-                <a:spcPts val="600"/>
-              </a:spcBef>
-              <a:spcAft>
-                <a:spcPts val="500"/>
-              </a:spcAft>
-            </a:pPr>
-            <a:r>
-              <a:rPr sz="1500" b="1" i="0" dirty="0">
-                <a:solidFill>
-                  <a:srgbClr val="3D8B00"/>
-                </a:solidFill>
-                <a:latin typeface="Calibri"/>
-              </a:rPr>
-              <a:t>▬ </a:t>
-            </a:r>
-            <a:r>
-              <a:rPr sz="1500" b="1" i="0" dirty="0">
-                <a:solidFill>
-                  <a:srgbClr val="0F1111"/>
-                </a:solidFill>
-                <a:latin typeface="Calibri"/>
-              </a:rPr>
-              <a:t>Our own work</a:t>
-            </a:r>
-          </a:p>
-          <a:p>
-            <a:pPr>
-              <a:spcBef>
+              </a:spcBef>
+              <a:spcAft>
                 <a:spcPts val="0"/>
-              </a:spcBef>
-              <a:spcAft>
-                <a:spcPts val="300"/>
-              </a:spcAft>
-            </a:pPr>
-            <a:r>
-              <a:rPr sz="1100" b="1" i="0" dirty="0">
-                <a:solidFill>
-                  <a:srgbClr val="3D8B00"/>
-                </a:solidFill>
-                <a:latin typeface="Calibri"/>
-              </a:rPr>
-              <a:t>▪ </a:t>
-            </a:r>
-            <a:r>
-              <a:rPr sz="1100" b="1" i="0" dirty="0">
-                <a:solidFill>
-                  <a:srgbClr val="0F1111"/>
-                </a:solidFill>
-                <a:latin typeface="Calibri"/>
-              </a:rPr>
-              <a:t>Source, evaluation and write-up </a:t>
-            </a:r>
-            <a:r>
-              <a:rPr sz="1100" b="0" i="0" dirty="0">
-                <a:solidFill>
-                  <a:srgbClr val="333B3B"/>
-                </a:solidFill>
-                <a:latin typeface="Calibri"/>
-              </a:rPr>
-              <a:t>— full implementation, 291 tests, the leakage audit, and the architecture in long form.</a:t>
-            </a:r>
-          </a:p>
-          <a:p>
-            <a:pPr>
-              <a:spcBef>
-                <a:spcPts val="100"/>
-              </a:spcBef>
-              <a:spcAft>
-                <a:spcPts val="0"/>
-              </a:spcAft>
-            </a:pPr>
-            <a:r>
-              <a:rPr sz="950" b="0" i="1" u="sng" dirty="0">
-                <a:solidFill>
-                  <a:srgbClr val="2F6B00"/>
-                </a:solidFill>
-                <a:latin typeface="Calibri"/>
-                <a:hlinkClick r:id="rId11"/>
-              </a:rPr>
-              <a:t>https://github.com/hotshot0104/SIH2026</a:t>
-            </a:r>
-          </a:p>
-          <a:p>
-            <a:pPr>
-              <a:spcBef>
-                <a:spcPts val="100"/>
-              </a:spcBef>
-              <a:spcAft>
-                <a:spcPts val="0"/>
-              </a:spcAft>
-            </a:pPr>
-            <a:r>
-              <a:rPr sz="950" b="0" i="1" u="sng" dirty="0">
-                <a:solidFill>
-                  <a:srgbClr val="2F6B00"/>
-                </a:solidFill>
-                <a:latin typeface="Calibri"/>
-                <a:hlinkClick r:id="rId12"/>
-              </a:rPr>
-              <a:t>https://dev.to/sameer0104/muleshield-ai-intercepting-cybercrime-cash-outs-before-the-trail-goes-cold-232g</a:t>
-            </a:r>
-          </a:p>
-          <a:p>
-            <a:pPr>
-              <a:spcBef>
-                <a:spcPts val="0"/>
-              </a:spcBef>
-              <a:spcAft>
-                <a:spcPts val="0"/>
-              </a:spcAft>
-            </a:pPr>
-            <a:endParaRPr sz="950" b="0" i="1" u="sng" dirty="0">
-              <a:solidFill>
-                <a:srgbClr val="2F6B00"/>
-              </a:solidFill>
-              <a:latin typeface="Calibri"/>
-              <a:hlinkClick r:id="rId12"/>
-            </a:endParaRPr>
+              </a:spcAft>
+            </a:pPr>
           </a:p>
         </p:txBody>
       </p:sp>
@@ -7596,6 +8207,870 @@
     <p:extLst>
       <p:ext uri="{BB962C8B-B14F-4D97-AF65-F5344CB8AC3E}">
         <p14:creationId xmlns:p14="http://schemas.microsoft.com/office/powerpoint/2010/main" val="3916788613"/>
+      </p:ext>
+    </p:extLst>
+  </p:cSld>
+  <p:clrMapOvr>
+    <a:masterClrMapping/>
+  </p:clrMapOvr>
+</p:sld>
+</file>
+
+<file path=ppt/slides/slide7.xml><?xml version="1.0" encoding="utf-8"?>
+<p:sld xmlns:a="http://schemas.openxmlformats.org/drawingml/2006/main" xmlns:r="http://schemas.openxmlformats.org/officeDocument/2006/relationships" xmlns:p="http://schemas.openxmlformats.org/presentationml/2006/main">
+  <p:cSld>
+    <p:spTree>
+      <p:nvGrpSpPr>
+        <p:cNvPr id="1" name=""/>
+        <p:cNvGrpSpPr/>
+        <p:nvPr/>
+      </p:nvGrpSpPr>
+      <p:grpSpPr>
+        <a:xfrm>
+          <a:off x="0" y="0"/>
+          <a:ext cx="0" cy="0"/>
+          <a:chOff x="0" y="0"/>
+          <a:chExt cx="0" cy="0"/>
+        </a:xfrm>
+      </p:grpSpPr>
+      <p:sp>
+        <p:nvSpPr>
+          <p:cNvPr id="10" name="Rectangle 9">
+            <a:extLst>
+              <a:ext uri="{FF2B5EF4-FFF2-40B4-BE49-F238E27FC236}">
+                <a16:creationId xmlns:a16="http://schemas.microsoft.com/office/drawing/2014/main" id="{AD4F69D3-EEB0-4C4C-9434-B9960FB5854C}"/>
+              </a:ext>
+            </a:extLst>
+          </p:cNvPr>
+          <p:cNvSpPr>
+            <a:spLocks noChangeArrowheads="1"/>
+          </p:cNvSpPr>
+          <p:nvPr/>
+        </p:nvSpPr>
+        <p:spPr bwMode="auto">
+          <a:xfrm>
+            <a:off x="0" y="6354762"/>
+            <a:ext cx="12191999" cy="503238"/>
+          </a:xfrm>
+          <a:prstGeom prst="rect">
+            <a:avLst/>
+          </a:prstGeom>
+          <a:solidFill>
+            <a:srgbClr val="0070C0"/>
+          </a:solidFill>
+          <a:ln w="9525">
+            <a:noFill/>
+            <a:miter lim="800000"/>
+            <a:headEnd/>
+            <a:tailEnd/>
+          </a:ln>
+          <a:effectLst>
+            <a:outerShdw dist="23000" dir="5400000" rotWithShape="0">
+              <a:srgbClr val="808080">
+                <a:alpha val="34999"/>
+              </a:srgbClr>
+            </a:outerShdw>
+          </a:effectLst>
+        </p:spPr>
+        <p:txBody>
+          <a:bodyPr anchor="ctr"/>
+          <a:lstStyle/>
+          <a:p>
+            <a:pPr marL="0" marR="0" lvl="0" indent="0" algn="ctr" defTabSz="457200" rtl="0" eaLnBrk="1" fontAlgn="auto" latinLnBrk="0" hangingPunct="1">
+              <a:lnSpc>
+                <a:spcPct val="100000"/>
+              </a:lnSpc>
+              <a:spcBef>
+                <a:spcPts val="0"/>
+              </a:spcBef>
+              <a:spcAft>
+                <a:spcPts val="0"/>
+              </a:spcAft>
+              <a:buClrTx/>
+              <a:buSzTx/>
+              <a:buFontTx/>
+              <a:buNone/>
+              <a:tabLst/>
+              <a:defRPr/>
+            </a:pPr>
+            <a:endParaRPr kumimoji="0" lang="en-US" sz="1800" b="0" i="0" u="none" strike="noStrike" kern="1200" cap="none" spc="0" normalizeH="0" baseline="0" noProof="0" dirty="0">
+              <a:ln>
+                <a:noFill/>
+              </a:ln>
+              <a:solidFill>
+                <a:srgbClr val="C0504D">
+                  <a:lumMod val="75000"/>
+                </a:srgbClr>
+              </a:solidFill>
+              <a:effectLst/>
+              <a:uLnTx/>
+              <a:uFillTx/>
+              <a:latin typeface="Calibri"/>
+              <a:ea typeface="ＭＳ Ｐゴシック" pitchFamily="1" charset="-128"/>
+              <a:cs typeface="+mn-cs"/>
+            </a:endParaRPr>
+          </a:p>
+        </p:txBody>
+      </p:sp>
+      <p:sp>
+        <p:nvSpPr>
+          <p:cNvPr id="6" name="Slide Number Placeholder 5"/>
+          <p:cNvSpPr>
+            <a:spLocks noGrp="1"/>
+          </p:cNvSpPr>
+          <p:nvPr>
+            <p:ph type="sldNum" sz="quarter" idx="12"/>
+          </p:nvPr>
+        </p:nvSpPr>
+        <p:spPr/>
+        <p:txBody>
+          <a:bodyPr/>
+          <a:lstStyle/>
+          <a:p>
+            <a:pPr marL="0" marR="0" lvl="0" indent="0" algn="r" defTabSz="457200" rtl="0" eaLnBrk="1" fontAlgn="base" latinLnBrk="0" hangingPunct="1">
+              <a:lnSpc>
+                <a:spcPct val="100000"/>
+              </a:lnSpc>
+              <a:spcBef>
+                <a:spcPct val="0"/>
+              </a:spcBef>
+              <a:spcAft>
+                <a:spcPct val="0"/>
+              </a:spcAft>
+              <a:buClrTx/>
+              <a:buSzTx/>
+              <a:buFontTx/>
+              <a:buNone/>
+              <a:tabLst/>
+              <a:defRPr/>
+            </a:pPr>
+            <a:fld id="{677C3CE7-23F7-4828-823C-E0205DF2CF97}" type="slidenum">
+              <a:rPr kumimoji="0" lang="en-US" sz="1200" b="1" i="0" u="none" strike="noStrike" kern="1200" cap="none" spc="0" normalizeH="0" baseline="0" noProof="0">
+                <a:ln>
+                  <a:noFill/>
+                </a:ln>
+                <a:solidFill>
+                  <a:prstClr val="white"/>
+                </a:solidFill>
+                <a:effectLst/>
+                <a:uLnTx/>
+                <a:uFillTx/>
+                <a:latin typeface="TradeGothic" pitchFamily="1" charset="0"/>
+                <a:ea typeface="ＭＳ Ｐゴシック" pitchFamily="1" charset="-128"/>
+                <a:cs typeface="+mn-cs"/>
+              </a:rPr>
+              <a:pPr marL="0" marR="0" lvl="0" indent="0" algn="r" defTabSz="457200" rtl="0" eaLnBrk="1" fontAlgn="base" latinLnBrk="0" hangingPunct="1">
+                <a:lnSpc>
+                  <a:spcPct val="100000"/>
+                </a:lnSpc>
+                <a:spcBef>
+                  <a:spcPct val="0"/>
+                </a:spcBef>
+                <a:spcAft>
+                  <a:spcPct val="0"/>
+                </a:spcAft>
+                <a:buClrTx/>
+                <a:buSzTx/>
+                <a:buFontTx/>
+                <a:buNone/>
+                <a:tabLst/>
+                <a:defRPr/>
+              </a:pPr>
+              <a:t>7</a:t>
+            </a:fld>
+            <a:endParaRPr kumimoji="0" lang="en-US" sz="1200" b="1" i="0" u="none" strike="noStrike" kern="1200" cap="none" spc="0" normalizeH="0" baseline="0" noProof="0" dirty="0">
+              <a:ln>
+                <a:noFill/>
+              </a:ln>
+              <a:solidFill>
+                <a:prstClr val="white"/>
+              </a:solidFill>
+              <a:effectLst/>
+              <a:uLnTx/>
+              <a:uFillTx/>
+              <a:latin typeface="TradeGothic" pitchFamily="1" charset="0"/>
+              <a:ea typeface="ＭＳ Ｐゴシック" pitchFamily="1" charset="-128"/>
+              <a:cs typeface="+mn-cs"/>
+            </a:endParaRPr>
+          </a:p>
+        </p:txBody>
+      </p:sp>
+      <p:sp>
+        <p:nvSpPr>
+          <p:cNvPr id="7" name="Footer Placeholder 6"/>
+          <p:cNvSpPr>
+            <a:spLocks noGrp="1"/>
+          </p:cNvSpPr>
+          <p:nvPr>
+            <p:ph type="ftr" sz="quarter" idx="11"/>
+          </p:nvPr>
+        </p:nvSpPr>
+        <p:spPr>
+          <a:xfrm>
+            <a:off x="4648200" y="6356353"/>
+            <a:ext cx="3204000" cy="365125"/>
+          </a:xfrm>
+        </p:spPr>
+        <p:txBody>
+          <a:bodyPr/>
+          <a:lstStyle/>
+          <a:p>
+            <a:pPr marL="0" marR="0" lvl="0" indent="0" algn="ctr" defTabSz="457200" rtl="0" eaLnBrk="1" fontAlgn="auto" latinLnBrk="0" hangingPunct="1">
+              <a:lnSpc>
+                <a:spcPct val="100000"/>
+              </a:lnSpc>
+              <a:spcBef>
+                <a:spcPts val="0"/>
+              </a:spcBef>
+              <a:spcAft>
+                <a:spcPts val="0"/>
+              </a:spcAft>
+              <a:buClrTx/>
+              <a:buSzTx/>
+              <a:buFontTx/>
+              <a:buNone/>
+              <a:tabLst/>
+              <a:defRPr/>
+            </a:pPr>
+            <a:r>
+              <a:rPr kumimoji="0" lang="en-US" sz="1200" b="0" i="0" u="none" strike="noStrike" kern="1200" cap="none" spc="0" normalizeH="0" baseline="0" noProof="0">
+                <a:ln>
+                  <a:noFill/>
+                </a:ln>
+                <a:solidFill>
+                  <a:prstClr val="white"/>
+                </a:solidFill>
+                <a:effectLst/>
+                <a:uLnTx/>
+                <a:uFillTx/>
+                <a:latin typeface="TradeGothic"/>
+                <a:ea typeface="+mn-ea"/>
+                <a:cs typeface="+mn-cs"/>
+              </a:rPr>
+              <a:t>@SIH Idea submission- Template</a:t>
+            </a:r>
+            <a:endParaRPr kumimoji="0" lang="en-US" sz="1200" b="0" i="0" u="none" strike="noStrike" kern="1200" cap="none" spc="0" normalizeH="0" baseline="0" noProof="0" dirty="0">
+              <a:ln>
+                <a:noFill/>
+              </a:ln>
+              <a:solidFill>
+                <a:prstClr val="white"/>
+              </a:solidFill>
+              <a:effectLst/>
+              <a:uLnTx/>
+              <a:uFillTx/>
+              <a:latin typeface="TradeGothic"/>
+              <a:ea typeface="+mn-ea"/>
+              <a:cs typeface="+mn-cs"/>
+            </a:endParaRPr>
+          </a:p>
+        </p:txBody>
+      </p:sp>
+      <p:sp>
+        <p:nvSpPr>
+          <p:cNvPr id="3" name="Round Diagonal Corner Rectangle 2"/>
+          <p:cNvSpPr/>
+          <p:nvPr/>
+        </p:nvSpPr>
+        <p:spPr>
+          <a:xfrm>
+            <a:off x="0" y="1791032"/>
+            <a:ext cx="12192000" cy="4319200"/>
+          </a:xfrm>
+          <a:prstGeom prst="round2DiagRect">
+            <a:avLst/>
+          </a:prstGeom>
+          <a:solidFill>
+            <a:schemeClr val="accent1">
+              <a:lumMod val="20000"/>
+              <a:lumOff val="80000"/>
+            </a:schemeClr>
+          </a:solidFill>
+          <a:ln w="38100"/>
+        </p:spPr>
+        <p:style>
+          <a:lnRef idx="1">
+            <a:schemeClr val="accent1"/>
+          </a:lnRef>
+          <a:fillRef idx="3">
+            <a:schemeClr val="accent1"/>
+          </a:fillRef>
+          <a:effectRef idx="2">
+            <a:schemeClr val="accent1"/>
+          </a:effectRef>
+          <a:fontRef idx="minor">
+            <a:schemeClr val="lt1"/>
+          </a:fontRef>
+        </p:style>
+        <p:txBody>
+          <a:bodyPr rtlCol="0" anchor="ctr"/>
+          <a:lstStyle/>
+          <a:p>
+            <a:pPr algn="ctr"/>
+            <a:endParaRPr lang="en-IN"/>
+          </a:p>
+        </p:txBody>
+      </p:sp>
+      <p:sp>
+        <p:nvSpPr>
+          <p:cNvPr id="12" name="Google Shape;100;p3"/>
+          <p:cNvSpPr txBox="1"/>
+          <p:nvPr/>
+        </p:nvSpPr>
+        <p:spPr>
+          <a:xfrm>
+            <a:off x="367832" y="1915454"/>
+            <a:ext cx="11764736" cy="4070356"/>
+          </a:xfrm>
+          <a:prstGeom prst="rect">
+            <a:avLst/>
+          </a:prstGeom>
+          <a:noFill/>
+          <a:ln>
+            <a:noFill/>
+          </a:ln>
+        </p:spPr>
+        <p:txBody>
+          <a:bodyPr spcFirstLastPara="1" wrap="square" lIns="91425" tIns="45700" rIns="91425" bIns="45700" anchor="t" anchorCtr="0">
+            <a:noAutofit/>
+          </a:bodyPr>
+          <a:lstStyle/>
+          <a:p>
+            <a:pPr marL="514350" marR="0" lvl="0" indent="-514350" algn="just" rtl="0">
+              <a:lnSpc>
+                <a:spcPct val="90000"/>
+              </a:lnSpc>
+              <a:spcBef>
+                <a:spcPts val="0"/>
+              </a:spcBef>
+              <a:spcAft>
+                <a:spcPts val="0"/>
+              </a:spcAft>
+              <a:buClr>
+                <a:schemeClr val="dk1"/>
+              </a:buClr>
+              <a:buSzPct val="100000"/>
+              <a:buFont typeface="Calibri"/>
+              <a:buAutoNum type="arabicPeriod"/>
+            </a:pPr>
+            <a:r>
+              <a:rPr lang="en-US" b="1" i="0" u="none" strike="noStrike" cap="none" dirty="0">
+                <a:solidFill>
+                  <a:schemeClr val="dk1"/>
+                </a:solidFill>
+                <a:latin typeface="Arial" panose="020B0604020202020204" pitchFamily="34" charset="0"/>
+                <a:ea typeface="Calibri"/>
+                <a:cs typeface="Arial" panose="020B0604020202020204" pitchFamily="34" charset="0"/>
+                <a:sym typeface="Calibri"/>
+              </a:rPr>
+              <a:t>Kindly keep the maximum slides limit up to six </a:t>
+            </a:r>
+            <a:r>
+              <a:rPr lang="en-US" b="1" i="0" u="none" strike="noStrike" cap="none" dirty="0">
+                <a:solidFill>
+                  <a:srgbClr val="C00000"/>
+                </a:solidFill>
+                <a:latin typeface="Arial" panose="020B0604020202020204" pitchFamily="34" charset="0"/>
+                <a:ea typeface="Calibri"/>
+                <a:cs typeface="Arial" panose="020B0604020202020204" pitchFamily="34" charset="0"/>
+                <a:sym typeface="Calibri"/>
+              </a:rPr>
+              <a:t>(6). </a:t>
+            </a:r>
+            <a:r>
+              <a:rPr lang="en-US" b="1" i="0" u="none" strike="noStrike" cap="none" dirty="0">
+                <a:solidFill>
+                  <a:schemeClr val="dk1"/>
+                </a:solidFill>
+                <a:latin typeface="Arial" panose="020B0604020202020204" pitchFamily="34" charset="0"/>
+                <a:ea typeface="Calibri"/>
+                <a:cs typeface="Arial" panose="020B0604020202020204" pitchFamily="34" charset="0"/>
+                <a:sym typeface="Calibri"/>
+              </a:rPr>
+              <a:t>( Including the </a:t>
+            </a:r>
+            <a:r>
+              <a:rPr lang="en-US" b="1" i="0" u="none" strike="noStrike" cap="none">
+                <a:solidFill>
+                  <a:schemeClr val="dk1"/>
+                </a:solidFill>
+                <a:latin typeface="Arial" panose="020B0604020202020204" pitchFamily="34" charset="0"/>
+                <a:ea typeface="Calibri"/>
+                <a:cs typeface="Arial" panose="020B0604020202020204" pitchFamily="34" charset="0"/>
+                <a:sym typeface="Calibri"/>
+              </a:rPr>
+              <a:t>title slide) </a:t>
+            </a:r>
+            <a:endParaRPr b="1" dirty="0">
+              <a:latin typeface="Arial" panose="020B0604020202020204" pitchFamily="34" charset="0"/>
+              <a:cs typeface="Arial" panose="020B0604020202020204" pitchFamily="34" charset="0"/>
+            </a:endParaRPr>
+          </a:p>
+          <a:p>
+            <a:pPr marL="514350" marR="0" lvl="0" indent="-514350" algn="just" rtl="0">
+              <a:lnSpc>
+                <a:spcPct val="90000"/>
+              </a:lnSpc>
+              <a:spcBef>
+                <a:spcPts val="1000"/>
+              </a:spcBef>
+              <a:spcAft>
+                <a:spcPts val="0"/>
+              </a:spcAft>
+              <a:buClr>
+                <a:schemeClr val="dk1"/>
+              </a:buClr>
+              <a:buSzPct val="100000"/>
+              <a:buFont typeface="Calibri"/>
+              <a:buAutoNum type="arabicPeriod"/>
+            </a:pPr>
+            <a:r>
+              <a:rPr lang="en-US" b="1" i="0" u="none" strike="noStrike" cap="none" dirty="0">
+                <a:solidFill>
+                  <a:schemeClr val="dk1"/>
+                </a:solidFill>
+                <a:latin typeface="Arial" panose="020B0604020202020204" pitchFamily="34" charset="0"/>
+                <a:ea typeface="Calibri"/>
+                <a:cs typeface="Arial" panose="020B0604020202020204" pitchFamily="34" charset="0"/>
+                <a:sym typeface="Calibri"/>
+              </a:rPr>
+              <a:t>Try to avoid paragraphs and post your idea in points /diagrams / Infographics /pictures </a:t>
+            </a:r>
+            <a:endParaRPr b="1" dirty="0">
+              <a:latin typeface="Arial" panose="020B0604020202020204" pitchFamily="34" charset="0"/>
+              <a:cs typeface="Arial" panose="020B0604020202020204" pitchFamily="34" charset="0"/>
+            </a:endParaRPr>
+          </a:p>
+          <a:p>
+            <a:pPr marL="514350" marR="0" lvl="0" indent="-514350" algn="just" rtl="0">
+              <a:lnSpc>
+                <a:spcPct val="90000"/>
+              </a:lnSpc>
+              <a:spcBef>
+                <a:spcPts val="1000"/>
+              </a:spcBef>
+              <a:spcAft>
+                <a:spcPts val="0"/>
+              </a:spcAft>
+              <a:buClr>
+                <a:schemeClr val="dk1"/>
+              </a:buClr>
+              <a:buSzPct val="100000"/>
+              <a:buFont typeface="Calibri"/>
+              <a:buAutoNum type="arabicPeriod"/>
+            </a:pPr>
+            <a:r>
+              <a:rPr lang="en-US" b="1" i="0" u="none" strike="noStrike" cap="none" dirty="0">
+                <a:solidFill>
+                  <a:schemeClr val="dk1"/>
+                </a:solidFill>
+                <a:latin typeface="Arial" panose="020B0604020202020204" pitchFamily="34" charset="0"/>
+                <a:ea typeface="Calibri"/>
+                <a:cs typeface="Arial" panose="020B0604020202020204" pitchFamily="34" charset="0"/>
+                <a:sym typeface="Calibri"/>
+              </a:rPr>
+              <a:t>Keep your explanation precise and easy to understand</a:t>
+            </a:r>
+            <a:endParaRPr b="1" dirty="0">
+              <a:latin typeface="Arial" panose="020B0604020202020204" pitchFamily="34" charset="0"/>
+              <a:cs typeface="Arial" panose="020B0604020202020204" pitchFamily="34" charset="0"/>
+            </a:endParaRPr>
+          </a:p>
+          <a:p>
+            <a:pPr marL="514350" marR="0" lvl="0" indent="-514350" algn="just" rtl="0">
+              <a:lnSpc>
+                <a:spcPct val="90000"/>
+              </a:lnSpc>
+              <a:spcBef>
+                <a:spcPts val="1000"/>
+              </a:spcBef>
+              <a:spcAft>
+                <a:spcPts val="0"/>
+              </a:spcAft>
+              <a:buClr>
+                <a:schemeClr val="dk1"/>
+              </a:buClr>
+              <a:buSzPct val="100000"/>
+              <a:buFont typeface="Calibri"/>
+              <a:buAutoNum type="arabicPeriod"/>
+            </a:pPr>
+            <a:r>
+              <a:rPr lang="en-US" b="1" i="0" u="none" strike="noStrike" cap="none" dirty="0">
+                <a:solidFill>
+                  <a:schemeClr val="dk1"/>
+                </a:solidFill>
+                <a:latin typeface="Arial" panose="020B0604020202020204" pitchFamily="34" charset="0"/>
+                <a:ea typeface="Calibri"/>
+                <a:cs typeface="Arial" panose="020B0604020202020204" pitchFamily="34" charset="0"/>
+                <a:sym typeface="Calibri"/>
+              </a:rPr>
+              <a:t>Idea should be unique and novel. </a:t>
+            </a:r>
+            <a:endParaRPr b="1" dirty="0">
+              <a:latin typeface="Arial" panose="020B0604020202020204" pitchFamily="34" charset="0"/>
+              <a:cs typeface="Arial" panose="020B0604020202020204" pitchFamily="34" charset="0"/>
+            </a:endParaRPr>
+          </a:p>
+          <a:p>
+            <a:pPr marL="514350" marR="0" lvl="0" indent="-514350" algn="just" rtl="0">
+              <a:lnSpc>
+                <a:spcPct val="90000"/>
+              </a:lnSpc>
+              <a:spcBef>
+                <a:spcPts val="1000"/>
+              </a:spcBef>
+              <a:spcAft>
+                <a:spcPts val="0"/>
+              </a:spcAft>
+              <a:buClr>
+                <a:schemeClr val="dk1"/>
+              </a:buClr>
+              <a:buSzPct val="100000"/>
+              <a:buFont typeface="Calibri"/>
+              <a:buAutoNum type="arabicPeriod"/>
+            </a:pPr>
+            <a:r>
+              <a:rPr lang="en-US" b="1" i="0" u="none" strike="noStrike" cap="none" dirty="0">
+                <a:solidFill>
+                  <a:schemeClr val="dk1"/>
+                </a:solidFill>
+                <a:latin typeface="Arial" panose="020B0604020202020204" pitchFamily="34" charset="0"/>
+                <a:ea typeface="Calibri"/>
+                <a:cs typeface="Arial" panose="020B0604020202020204" pitchFamily="34" charset="0"/>
+                <a:sym typeface="Calibri"/>
+              </a:rPr>
+              <a:t>You can only use provided </a:t>
+            </a:r>
+            <a:r>
+              <a:rPr lang="en-US" b="1" dirty="0">
+                <a:solidFill>
+                  <a:schemeClr val="dk1"/>
+                </a:solidFill>
+                <a:latin typeface="Arial" panose="020B0604020202020204" pitchFamily="34" charset="0"/>
+                <a:ea typeface="Calibri"/>
+                <a:cs typeface="Arial" panose="020B0604020202020204" pitchFamily="34" charset="0"/>
+                <a:sym typeface="Calibri"/>
+              </a:rPr>
+              <a:t>template</a:t>
+            </a:r>
+            <a:r>
+              <a:rPr lang="en-US" b="1" i="0" u="none" strike="noStrike" cap="none" dirty="0">
+                <a:solidFill>
+                  <a:schemeClr val="dk1"/>
+                </a:solidFill>
+                <a:latin typeface="Arial" panose="020B0604020202020204" pitchFamily="34" charset="0"/>
+                <a:ea typeface="Calibri"/>
+                <a:cs typeface="Arial" panose="020B0604020202020204" pitchFamily="34" charset="0"/>
+                <a:sym typeface="Calibri"/>
+              </a:rPr>
+              <a:t> for making the </a:t>
+            </a:r>
+            <a:r>
+              <a:rPr lang="en-US" b="1" dirty="0">
+                <a:solidFill>
+                  <a:schemeClr val="dk1"/>
+                </a:solidFill>
+                <a:latin typeface="Arial" panose="020B0604020202020204" pitchFamily="34" charset="0"/>
+                <a:ea typeface="Calibri"/>
+                <a:cs typeface="Arial" panose="020B0604020202020204" pitchFamily="34" charset="0"/>
+                <a:sym typeface="Calibri"/>
+              </a:rPr>
+              <a:t>PPT</a:t>
+            </a:r>
+            <a:r>
+              <a:rPr lang="en-US" b="1" i="0" u="none" strike="noStrike" cap="none" dirty="0">
+                <a:solidFill>
+                  <a:schemeClr val="dk1"/>
+                </a:solidFill>
+                <a:latin typeface="Arial" panose="020B0604020202020204" pitchFamily="34" charset="0"/>
+                <a:ea typeface="Calibri"/>
+                <a:cs typeface="Arial" panose="020B0604020202020204" pitchFamily="34" charset="0"/>
+                <a:sym typeface="Calibri"/>
+              </a:rPr>
+              <a:t> without changing the idea details pointers (mentioned in previous slides).</a:t>
+            </a:r>
+            <a:endParaRPr b="1" i="0" u="none" strike="noStrike" cap="none" dirty="0">
+              <a:solidFill>
+                <a:schemeClr val="dk1"/>
+              </a:solidFill>
+              <a:latin typeface="Arial" panose="020B0604020202020204" pitchFamily="34" charset="0"/>
+              <a:ea typeface="Calibri"/>
+              <a:cs typeface="Arial" panose="020B0604020202020204" pitchFamily="34" charset="0"/>
+              <a:sym typeface="Calibri"/>
+            </a:endParaRPr>
+          </a:p>
+          <a:p>
+            <a:pPr marL="514350" marR="0" lvl="0" indent="-514350" algn="just" rtl="0">
+              <a:lnSpc>
+                <a:spcPct val="90000"/>
+              </a:lnSpc>
+              <a:spcBef>
+                <a:spcPts val="1000"/>
+              </a:spcBef>
+              <a:spcAft>
+                <a:spcPts val="0"/>
+              </a:spcAft>
+              <a:buClr>
+                <a:schemeClr val="dk1"/>
+              </a:buClr>
+              <a:buSzPct val="100000"/>
+              <a:buFont typeface="Calibri"/>
+              <a:buAutoNum type="arabicPeriod"/>
+            </a:pPr>
+            <a:r>
+              <a:rPr lang="en-US" b="1" i="0" u="none" strike="noStrike" cap="none" dirty="0">
+                <a:solidFill>
+                  <a:schemeClr val="dk1"/>
+                </a:solidFill>
+                <a:latin typeface="Arial" panose="020B0604020202020204" pitchFamily="34" charset="0"/>
+                <a:ea typeface="Calibri"/>
+                <a:cs typeface="Arial" panose="020B0604020202020204" pitchFamily="34" charset="0"/>
+                <a:sym typeface="Calibri"/>
+              </a:rPr>
+              <a:t>You need to save the file in PDF and upload the same on portal. No PPT, Word Doc or any other format will be supported.</a:t>
+            </a:r>
+            <a:endParaRPr b="1" dirty="0">
+              <a:latin typeface="Arial" panose="020B0604020202020204" pitchFamily="34" charset="0"/>
+              <a:cs typeface="Arial" panose="020B0604020202020204" pitchFamily="34" charset="0"/>
+            </a:endParaRPr>
+          </a:p>
+          <a:p>
+            <a:pPr marL="514350" marR="0" lvl="0" indent="-349885" algn="just" rtl="0">
+              <a:lnSpc>
+                <a:spcPct val="90000"/>
+              </a:lnSpc>
+              <a:spcBef>
+                <a:spcPts val="1000"/>
+              </a:spcBef>
+              <a:spcAft>
+                <a:spcPts val="0"/>
+              </a:spcAft>
+              <a:buClr>
+                <a:schemeClr val="dk1"/>
+              </a:buClr>
+              <a:buSzPct val="100000"/>
+              <a:buFont typeface="Calibri"/>
+              <a:buNone/>
+            </a:pPr>
+            <a:endParaRPr b="1" i="0" u="none" strike="noStrike" cap="none" dirty="0">
+              <a:solidFill>
+                <a:schemeClr val="dk1"/>
+              </a:solidFill>
+              <a:latin typeface="Arial" panose="020B0604020202020204" pitchFamily="34" charset="0"/>
+              <a:ea typeface="Calibri"/>
+              <a:cs typeface="Arial" panose="020B0604020202020204" pitchFamily="34" charset="0"/>
+              <a:sym typeface="Calibri"/>
+            </a:endParaRPr>
+          </a:p>
+          <a:p>
+            <a:pPr marL="0" marR="0" lvl="0" indent="0" algn="just" rtl="0">
+              <a:lnSpc>
+                <a:spcPct val="90000"/>
+              </a:lnSpc>
+              <a:spcBef>
+                <a:spcPts val="1000"/>
+              </a:spcBef>
+              <a:spcAft>
+                <a:spcPts val="0"/>
+              </a:spcAft>
+              <a:buClr>
+                <a:schemeClr val="dk1"/>
+              </a:buClr>
+              <a:buSzPct val="100000"/>
+              <a:buFont typeface="Arial"/>
+              <a:buNone/>
+            </a:pPr>
+            <a:r>
+              <a:rPr lang="en-US" b="1" i="0" u="none" strike="noStrike" cap="none" dirty="0">
+                <a:solidFill>
+                  <a:srgbClr val="C00000"/>
+                </a:solidFill>
+                <a:latin typeface="Arial" panose="020B0604020202020204" pitchFamily="34" charset="0"/>
+                <a:ea typeface="Calibri"/>
+                <a:cs typeface="Arial" panose="020B0604020202020204" pitchFamily="34" charset="0"/>
+                <a:sym typeface="Calibri"/>
+              </a:rPr>
+              <a:t>Note - You can delete this slide (Important Pointers) when you upload the details of your idea on SIH portal.</a:t>
+            </a:r>
+            <a:endParaRPr b="1" dirty="0">
+              <a:solidFill>
+                <a:srgbClr val="C00000"/>
+              </a:solidFill>
+              <a:latin typeface="Arial" panose="020B0604020202020204" pitchFamily="34" charset="0"/>
+              <a:cs typeface="Arial" panose="020B0604020202020204" pitchFamily="34" charset="0"/>
+            </a:endParaRPr>
+          </a:p>
+          <a:p>
+            <a:pPr marL="914400" marR="0" lvl="1" indent="-316230" algn="just" rtl="0">
+              <a:lnSpc>
+                <a:spcPct val="90000"/>
+              </a:lnSpc>
+              <a:spcBef>
+                <a:spcPts val="500"/>
+              </a:spcBef>
+              <a:spcAft>
+                <a:spcPts val="0"/>
+              </a:spcAft>
+              <a:buClr>
+                <a:schemeClr val="dk1"/>
+              </a:buClr>
+              <a:buSzPct val="100000"/>
+              <a:buFont typeface="Calibri"/>
+              <a:buNone/>
+            </a:pPr>
+            <a:endParaRPr sz="2000" b="1" i="0" u="none" strike="noStrike" cap="none" dirty="0">
+              <a:solidFill>
+                <a:schemeClr val="dk1"/>
+              </a:solidFill>
+              <a:latin typeface="Arial" panose="020B0604020202020204" pitchFamily="34" charset="0"/>
+              <a:ea typeface="Calibri"/>
+              <a:cs typeface="Arial" panose="020B0604020202020204" pitchFamily="34" charset="0"/>
+              <a:sym typeface="Calibri"/>
+            </a:endParaRPr>
+          </a:p>
+        </p:txBody>
+      </p:sp>
+      <p:sp>
+        <p:nvSpPr>
+          <p:cNvPr id="4" name="TextBox 3"/>
+          <p:cNvSpPr txBox="1"/>
+          <p:nvPr/>
+        </p:nvSpPr>
+        <p:spPr>
+          <a:xfrm>
+            <a:off x="1393371" y="107066"/>
+            <a:ext cx="8410540" cy="646331"/>
+          </a:xfrm>
+          <a:prstGeom prst="rect">
+            <a:avLst/>
+          </a:prstGeom>
+          <a:noFill/>
+        </p:spPr>
+        <p:txBody>
+          <a:bodyPr wrap="square" rtlCol="0">
+            <a:spAutoFit/>
+          </a:bodyPr>
+          <a:lstStyle/>
+          <a:p>
+            <a:pPr algn="ctr"/>
+            <a:r>
+              <a:rPr lang="en-US" sz="3600" b="1" dirty="0">
+                <a:latin typeface="Times New Roman" panose="02020603050405020304" pitchFamily="18" charset="0"/>
+                <a:cs typeface="Times New Roman" panose="02020603050405020304" pitchFamily="18" charset="0"/>
+              </a:rPr>
+              <a:t>IMPORTANT INSTRUCTIONS</a:t>
+            </a:r>
+            <a:endParaRPr lang="en-IN" sz="3600" b="1" dirty="0">
+              <a:latin typeface="Times New Roman" panose="02020603050405020304" pitchFamily="18" charset="0"/>
+              <a:cs typeface="Times New Roman" panose="02020603050405020304" pitchFamily="18" charset="0"/>
+            </a:endParaRPr>
+          </a:p>
+        </p:txBody>
+      </p:sp>
+      <p:sp>
+        <p:nvSpPr>
+          <p:cNvPr id="5" name="TextBox 4"/>
+          <p:cNvSpPr txBox="1"/>
+          <p:nvPr/>
+        </p:nvSpPr>
+        <p:spPr>
+          <a:xfrm>
+            <a:off x="602343" y="1181900"/>
+            <a:ext cx="9557657" cy="341632"/>
+          </a:xfrm>
+          <a:prstGeom prst="rect">
+            <a:avLst/>
+          </a:prstGeom>
+          <a:noFill/>
+        </p:spPr>
+        <p:txBody>
+          <a:bodyPr wrap="square" rtlCol="0">
+            <a:spAutoFit/>
+          </a:bodyPr>
+          <a:lstStyle/>
+          <a:p>
+            <a:pPr algn="just">
+              <a:lnSpc>
+                <a:spcPct val="90000"/>
+              </a:lnSpc>
+              <a:spcBef>
+                <a:spcPts val="1000"/>
+              </a:spcBef>
+              <a:spcAft>
+                <a:spcPts val="0"/>
+              </a:spcAft>
+              <a:buClr>
+                <a:schemeClr val="dk1"/>
+              </a:buClr>
+              <a:buSzPct val="100000"/>
+            </a:pPr>
+            <a:r>
+              <a:rPr lang="en-US" b="1" dirty="0">
+                <a:solidFill>
+                  <a:schemeClr val="dk1"/>
+                </a:solidFill>
+                <a:latin typeface="Arial" panose="020B0604020202020204" pitchFamily="34" charset="0"/>
+                <a:ea typeface="Calibri"/>
+                <a:cs typeface="Arial" panose="020B0604020202020204" pitchFamily="34" charset="0"/>
+              </a:rPr>
+              <a:t>Please ensure below pointers are met while submitting the Idea PPT:</a:t>
+            </a:r>
+            <a:endParaRPr lang="en-IN" b="1" dirty="0">
+              <a:solidFill>
+                <a:schemeClr val="dk1"/>
+              </a:solidFill>
+              <a:latin typeface="Arial" panose="020B0604020202020204" pitchFamily="34" charset="0"/>
+              <a:ea typeface="Calibri"/>
+              <a:cs typeface="Arial" panose="020B0604020202020204" pitchFamily="34" charset="0"/>
+            </a:endParaRPr>
+          </a:p>
+        </p:txBody>
+      </p:sp>
+      <p:pic>
+        <p:nvPicPr>
+          <p:cNvPr id="11" name="Picture 2" descr="https://www.sih.gov.in/img1/SIH-Logo.png"/>
+          <p:cNvPicPr>
+            <a:picLocks noChangeAspect="1" noChangeArrowheads="1"/>
+          </p:cNvPicPr>
+          <p:nvPr/>
+        </p:nvPicPr>
+        <p:blipFill>
+          <a:blip r:embed="rId3">
+            <a:extLst>
+              <a:ext uri="{28A0092B-C50C-407E-A947-70E740481C1C}">
+                <a14:useLocalDpi xmlns:a14="http://schemas.microsoft.com/office/drawing/2010/main" val="0"/>
+              </a:ext>
+            </a:extLst>
+          </a:blip>
+          <a:srcRect/>
+          <a:stretch>
+            <a:fillRect/>
+          </a:stretch>
+        </p:blipFill>
+        <p:spPr bwMode="auto">
+          <a:xfrm>
+            <a:off x="9841366" y="57097"/>
+            <a:ext cx="2209120" cy="1122868"/>
+          </a:xfrm>
+          <a:prstGeom prst="rect">
+            <a:avLst/>
+          </a:prstGeom>
+          <a:noFill/>
+          <a:extLst>
+            <a:ext uri="{909E8E84-426E-40DD-AFC4-6F175D3DCCD1}">
+              <a14:hiddenFill xmlns:a14="http://schemas.microsoft.com/office/drawing/2010/main">
+                <a:solidFill>
+                  <a:srgbClr val="FFFFFF"/>
+                </a:solidFill>
+              </a14:hiddenFill>
+            </a:ext>
+          </a:extLst>
+        </p:spPr>
+      </p:pic>
+    </p:spTree>
+    <p:extLst>
+      <p:ext uri="{BB962C8B-B14F-4D97-AF65-F5344CB8AC3E}">
+        <p14:creationId xmlns:p14="http://schemas.microsoft.com/office/powerpoint/2010/main" val="1588084416"/>
       </p:ext>
     </p:extLst>
   </p:cSld>

</xml_diff>